<commit_message>
Video 05: eigenes Beispiel zur Schlüsselanzahl (keine Überschneidung mit der Nachschreibklausur)
Co-Authored-By: Claude Opus 5.5 <noreply@anthropic.com>
Claude-Session: https://claude.ai/code/session_01JKXVQqFeKVmyQ9jfHw4db3
</commit_message>
<xml_diff>
--- a/materialien/Videos/05_Schluesselproblem_asymmetrisch_hybrid/KR_Video_05_Schluesselproblem_asymmetrisch_hybrid_Folien.pptx
+++ b/materialien/Videos/05_Schluesselproblem_asymmetrisch_hybrid/KR_Video_05_Schluesselproblem_asymmetrisch_hybrid_Folien.pptx
@@ -125,31 +125,31 @@
   <p:extLst>
     <p:ext uri="{521415D9-36F7-43E2-AB2F-B90AF26B5E84}">
       <p14:sectionLst xmlns:p14="http://schemas.microsoft.com/office/powerpoint/2010/main">
-        <p14:section name="Einstieg" id="{e9444beb-6803-47d1-b142-d856b65c0838}">
+        <p14:section name="Einstieg" id="{9afa47bf-2e9d-9f65-0e54-5b566920a4aa}">
           <p14:sldIdLst>
             <p14:sldId id="256"/>
             <p14:sldId id="257"/>
           </p14:sldIdLst>
         </p14:section>
-        <p14:section name="Schlüssel zählen" id="{24dc98fd-2a9e-18bb-a031-8c4b5051567d}">
+        <p14:section name="Schlüssel zählen" id="{0a597216-3421-1ff8-8966-4807f42a2722}">
           <p14:sldIdLst>
             <p14:sldId id="258"/>
             <p14:sldId id="259"/>
           </p14:sldIdLst>
         </p14:section>
-        <p14:section name="Selbst ausprobieren" id="{f011d470-9c71-0433-f118-fa35f3b47db0}">
+        <p14:section name="Selbst ausprobieren" id="{b1e1f00d-cacf-8250-cabb-68e7366f3aa3}">
           <p14:sldIdLst>
             <p14:sldId id="260"/>
             <p14:sldId id="261"/>
           </p14:sldIdLst>
         </p14:section>
-        <p14:section name="Öffentlich und privat" id="{0a8c56e9-cb08-65f4-3736-ca3bd2ba6f1a}">
+        <p14:section name="Öffentlich und privat" id="{3db4be3e-1b61-a4d4-edd7-8a2f42f2b671}">
           <p14:sldIdLst>
             <p14:sldId id="262"/>
             <p14:sldId id="263"/>
           </p14:sldIdLst>
         </p14:section>
-        <p14:section name="Diffie-Hellman" id="{a7b99918-3f0f-bc17-add5-4df85bee0b4a}">
+        <p14:section name="Diffie-Hellman" id="{3eadc160-493d-9826-3ac6-42e33e9b6298}">
           <p14:sldIdLst>
             <p14:sldId id="264"/>
             <p14:sldId id="265"/>
@@ -157,28 +157,28 @@
             <p14:sldId id="267"/>
           </p14:sldIdLst>
         </p14:section>
-        <p14:section name="RSA" id="{7ca354e6-8d5f-c302-13b9-2276c62b36c9}">
+        <p14:section name="RSA" id="{95c9259a-f5db-c1da-4490-2d622d9b923a}">
           <p14:sldIdLst>
             <p14:sldId id="268"/>
           </p14:sldIdLst>
         </p14:section>
-        <p14:section name="Vergleich" id="{555fcad6-a2e1-7c55-480a-f7b807b4611b}">
+        <p14:section name="Vergleich" id="{6b2d979a-93cf-573c-c5e5-8755c11bad36}">
           <p14:sldIdLst>
             <p14:sldId id="269"/>
           </p14:sldIdLst>
         </p14:section>
-        <p14:section name="Hybridverfahren" id="{f2b0ac0a-b127-8c13-58f8-48d37cf26713}">
+        <p14:section name="Hybridverfahren" id="{b2d23506-0832-fec9-616d-7fa2da7ad519}">
           <p14:sldIdLst>
             <p14:sldId id="270"/>
             <p14:sldId id="271"/>
           </p14:sldIdLst>
         </p14:section>
-        <p14:section name="Typische Fehler" id="{fc228aef-1580-f968-9803-c9a447c468f1}">
+        <p14:section name="Typische Fehler" id="{a4aa06b8-7aa1-b75a-32a7-40abd58b3df3}">
           <p14:sldIdLst>
             <p14:sldId id="272"/>
           </p14:sldIdLst>
         </p14:section>
-        <p14:section name="Zusammenfassung" id="{8674e7c1-a1b9-5847-0281-130ceebaa443}">
+        <p14:section name="Zusammenfassung" id="{dfb24201-5838-3333-f1e7-f1f676905353}">
           <p14:sldIdLst>
             <p14:sldId id="273"/>
             <p14:sldId id="274"/>
@@ -1834,7 +1834,7 @@
             <a:r>
               <a:rPr lang="en-US" dirty="0"/>
               <a:t>[Kapitel: Selbst ausprobieren]
-SPRECHERTEXT: Jetzt du. Dreizehn Leuchttürme an einer Küste wollen paarweise verschlüsselt funken. Bestimme die Anzahl der Schlüssel – symmetrisch und asymmetrisch. Und wie viele kommen jeweils hinzu, wenn ein vierzehnter Leuchtturm gebaut wird? Halte das Video an.
+SPRECHERTEXT: Jetzt du. Siebzehn Leuchttürme an einer Küste wollen paarweise verschlüsselt funken. Bestimme die Anzahl der Schlüssel – symmetrisch und asymmetrisch. Und wie viele kommen jeweils hinzu, wenn ein achtzehnter Leuchtturm gebaut wird? Halte das Video an.
 PAUSE: 5 s Einblendung „⏸ Video anhalten“</a:t>
             </a:r>
             <a:endParaRPr lang="en-US" dirty="0"/>
@@ -1923,7 +1923,7 @@
           <a:p>
             <a:r>
               <a:rPr lang="en-US" dirty="0"/>
-              <a:t>SPRECHERTEXT: Die Auflösung. Symmetrisch: dreizehn mal zwölf durch zwei, achtundsiebzig Schlüssel. Asymmetrisch: zwei mal dreizehn, sechsundzwanzig. Kommt der vierzehnte Leuchtturm dazu, braucht er symmetrisch dreizehn neue Schlüssel, asymmetrisch nur zwei. Die typischen Fehler sind Falle P7: das Durch-zwei vergessen, oder ein Schlüsselpaar als einen einzigen Schlüssel zählen.</a:t>
+              <a:t>SPRECHERTEXT: Die Auflösung. Symmetrisch: siebzehn mal sechzehn durch zwei, hundertsechsunddreißig Schlüssel. Asymmetrisch: zwei mal siebzehn, vierunddreißig. Kommt der achtzehnte Leuchtturm dazu, braucht er symmetrisch siebzehn neue Schlüssel, asymmetrisch nur zwei. Die typischen Fehler sind Falle P7: das Durch-zwei vergessen, oder ein Schlüsselpaar als einen einzigen Schlüssel zählen.</a:t>
             </a:r>
             <a:endParaRPr lang="en-US" dirty="0"/>
           </a:p>
@@ -13871,7 +13871,7 @@
                   <a:srgbClr val="1B1B1F"/>
                 </a:solidFill>
               </a:rPr>
-              <a:t>13 Leuchttürme</a:t>
+              <a:t>17 Leuchttürme</a:t>
             </a:r>
             <a:r>
               <a:rPr lang="en-US" sz="2200" dirty="0">
@@ -13895,7 +13895,7 @@
                   <a:srgbClr val="1B1B1F"/>
                 </a:solidFill>
               </a:rPr>
-              <a:t> die Anzahl der Schlüssel symmetrisch und asymmetrisch. Wie viele kommen jeweils hinzu, wenn ein 14. Leuchtturm dazukommt?</a:t>
+              <a:t> die Anzahl der Schlüssel symmetrisch und asymmetrisch. Wie viele kommen jeweils hinzu, wenn ein 18. Leuchtturm dazukommt?</a:t>
             </a:r>
             <a:endParaRPr lang="en-US" sz="2200" dirty="0"/>
           </a:p>
@@ -14396,7 +14396,7 @@
                           <a:ea typeface="Calibri" pitchFamily="34" charset="-122"/>
                           <a:cs typeface="Calibri" pitchFamily="34" charset="-120"/>
                         </a:rPr>
-                        <a:t>13 Leuchttürme</a:t>
+                        <a:t>17 Leuchttürme</a:t>
                       </a:r>
                       <a:endParaRPr lang="en-US" sz="1800" dirty="0">
                         <a:latin typeface="Calibri" charset="0"/>
@@ -14464,7 +14464,7 @@
                           <a:ea typeface="Calibri" pitchFamily="34" charset="-122"/>
                           <a:cs typeface="Calibri" pitchFamily="34" charset="-120"/>
                         </a:rPr>
-                        <a:t>13 · 12 / 2 = </a:t>
+                        <a:t>17 · 16 / 2 = </a:t>
                       </a:r>
                       <a:r>
                         <a:rPr lang="en-US" sz="1800" b="1" dirty="0">
@@ -14475,7 +14475,7 @@
                           <a:ea typeface="Calibri" pitchFamily="34" charset="-122"/>
                           <a:cs typeface="Calibri" pitchFamily="34" charset="-120"/>
                         </a:rPr>
-                        <a:t>78</a:t>
+                        <a:t>136</a:t>
                       </a:r>
                       <a:endParaRPr lang="en-US" sz="1800" dirty="0">
                         <a:latin typeface="Calibri" charset="0"/>
@@ -14543,7 +14543,7 @@
                           <a:ea typeface="Calibri" pitchFamily="34" charset="-122"/>
                           <a:cs typeface="Calibri" pitchFamily="34" charset="-120"/>
                         </a:rPr>
-                        <a:t>2 · 13 = </a:t>
+                        <a:t>2 · 17 = </a:t>
                       </a:r>
                       <a:r>
                         <a:rPr lang="en-US" sz="1800" b="1" dirty="0">
@@ -14554,7 +14554,7 @@
                           <a:ea typeface="Calibri" pitchFamily="34" charset="-122"/>
                           <a:cs typeface="Calibri" pitchFamily="34" charset="-120"/>
                         </a:rPr>
-                        <a:t>26</a:t>
+                        <a:t>34</a:t>
                       </a:r>
                       <a:endParaRPr lang="en-US" sz="1800" dirty="0">
                         <a:latin typeface="Calibri" charset="0"/>
@@ -14624,7 +14624,7 @@
                           <a:ea typeface="Calibri" pitchFamily="34" charset="-122"/>
                           <a:cs typeface="Calibri" pitchFamily="34" charset="-120"/>
                         </a:rPr>
-                        <a:t>der 14. kommt dazu</a:t>
+                        <a:t>der 18. kommt dazu</a:t>
                       </a:r>
                       <a:endParaRPr lang="en-US" sz="1800" dirty="0">
                         <a:latin typeface="Calibri" charset="0"/>
@@ -14692,7 +14692,7 @@
                           <a:ea typeface="Calibri" pitchFamily="34" charset="-122"/>
                           <a:cs typeface="Calibri" pitchFamily="34" charset="-120"/>
                         </a:rPr>
-                        <a:t>+ 13</a:t>
+                        <a:t>+ 17</a:t>
                       </a:r>
                       <a:endParaRPr lang="en-US" sz="1800" dirty="0">
                         <a:latin typeface="Calibri" charset="0"/>
@@ -14862,7 +14862,7 @@
                   <a:srgbClr val="1B1B1F"/>
                 </a:solidFill>
               </a:rPr>
-              <a:t>: 13 · 12 = 156 ohne „/ 2“ · Schlüsselpaar als </a:t>
+              <a:t>: 17 · 16 = 272 ohne „/ 2“ · Schlüsselpaar als </a:t>
             </a:r>
             <a:r>
               <a:rPr lang="en-US" sz="2200" b="1" dirty="0">
@@ -14878,7 +14878,7 @@
                   <a:srgbClr val="1B1B1F"/>
                 </a:solidFill>
               </a:rPr>
-              <a:t> Schlüssel gezählt (13)</a:t>
+              <a:t> Schlüssel gezählt (17)</a:t>
             </a:r>
             <a:endParaRPr lang="en-US" sz="2200" dirty="0"/>
           </a:p>

</xml_diff>